<commit_message>
SAF Q3 2026: update from the Q3 revenue call transcript
Corrects spare parts (+17% in USD) and drops unverified aftermarket and
OE growth figures; adds the CEO quote, the LEAP-1B profit shift (low
three digits, EUR m), capex above 6% of sales, the 2027 surtax draft and
the cabin divestment.

Co-Authored-By: Claude Opus 5.5 <noreply@anthropic.com>
Claude-Session: https://claude.ai/code/session_014d3kFaWCeVNznnbSptWmJY
</commit_message>
<xml_diff>
--- a/reports/SAF_Q3_2026/Earnings_Update_SAF_Q32026.pptx
+++ b/reports/SAF_Q3_2026/Earnings_Update_SAF_Q32026.pptx
@@ -1301,13 +1301,119 @@
       </p:sp>
       <p:sp>
         <p:nvSpPr>
-          <p:cNvPr id="9" name="Text 5"/>
-          <p:cNvSpPr txBox="1"/>
+          <p:cNvPr id="9" name="Shape 5"/>
+          <p:cNvSpPr/>
           <p:nvPr/>
         </p:nvSpPr>
         <p:spPr>
           <a:xfrm>
             <a:off x="539496" y="1612138"/>
+            <a:ext cx="42977" cy="573786"/>
+          </a:xfrm>
+          <a:prstGeom prst="rect">
+            <a:avLst/>
+          </a:prstGeom>
+          <a:solidFill>
+            <a:srgbClr val="FF6C0E"/>
+          </a:solidFill>
+          <a:ln w="12700">
+            <a:solidFill>
+              <a:srgbClr val="FF6C0E"/>
+            </a:solidFill>
+            <a:prstDash val="solid"/>
+          </a:ln>
+        </p:spPr>
+      </p:sp>
+      <p:sp>
+        <p:nvSpPr>
+          <p:cNvPr id="10" name="Text 6"/>
+          <p:cNvSpPr txBox="1"/>
+          <p:nvPr/>
+        </p:nvSpPr>
+        <p:spPr>
+          <a:xfrm>
+            <a:off x="722376" y="1630426"/>
+            <a:ext cx="6300216" cy="336042"/>
+          </a:xfrm>
+          <a:prstGeom prst="rect">
+            <a:avLst/>
+          </a:prstGeom>
+          <a:noFill/>
+          <a:ln/>
+        </p:spPr>
+        <p:txBody>
+          <a:bodyPr wrap="square" lIns="0" tIns="0" rIns="0" bIns="0" rtlCol="0" anchor="t"/>
+          <a:lstStyle/>
+          <a:p>
+            <a:pPr indent="0" marL="0">
+              <a:lnSpc>
+                <a:spcPct val="112500"/>
+              </a:lnSpc>
+              <a:buNone/>
+            </a:pPr>
+            <a:r>
+              <a:rPr lang="en-US" sz="980" b="1" dirty="0">
+                <a:solidFill>
+                  <a:srgbClr val="202945"/>
+                </a:solidFill>
+                <a:latin typeface="Nunito" pitchFamily="34" charset="0"/>
+                <a:ea typeface="Nunito" pitchFamily="34" charset="-122"/>
+                <a:cs typeface="Nunito" pitchFamily="34" charset="-120"/>
+              </a:rPr>
+              <a:t>“That’s what we see, and this is why we are fully confident and basically the end of the year is somehow ballistic now. We are very confident in 2027, and we are still confident in 2028.”</a:t>
+            </a:r>
+            <a:endParaRPr lang="en-US" sz="980" dirty="0"/>
+          </a:p>
+        </p:txBody>
+      </p:sp>
+      <p:sp>
+        <p:nvSpPr>
+          <p:cNvPr id="11" name="Text 7"/>
+          <p:cNvSpPr txBox="1"/>
+          <p:nvPr/>
+        </p:nvSpPr>
+        <p:spPr>
+          <a:xfrm>
+            <a:off x="722376" y="2003044"/>
+            <a:ext cx="6300216" cy="155448"/>
+          </a:xfrm>
+          <a:prstGeom prst="rect">
+            <a:avLst/>
+          </a:prstGeom>
+          <a:noFill/>
+          <a:ln/>
+        </p:spPr>
+        <p:txBody>
+          <a:bodyPr wrap="square" lIns="0" tIns="0" rIns="0" bIns="0" rtlCol="0" anchor="t"/>
+          <a:lstStyle/>
+          <a:p>
+            <a:pPr indent="0" marL="0">
+              <a:buNone/>
+            </a:pPr>
+            <a:r>
+              <a:rPr lang="en-US" sz="760" b="1" dirty="0">
+                <a:solidFill>
+                  <a:srgbClr val="6B7280"/>
+                </a:solidFill>
+                <a:latin typeface="Nunito" pitchFamily="34" charset="0"/>
+                <a:ea typeface="Nunito" pitchFamily="34" charset="-122"/>
+                <a:cs typeface="Nunito" pitchFamily="34" charset="-120"/>
+              </a:rPr>
+              <a:t>Olivier Andriès, Chief Executive Officer, Q3 2026 revenue call, 23 October 2026</a:t>
+            </a:r>
+            <a:endParaRPr lang="en-US" sz="760" dirty="0"/>
+          </a:p>
+        </p:txBody>
+      </p:sp>
+      <p:sp>
+        <p:nvSpPr>
+          <p:cNvPr id="12" name="Text 8"/>
+          <p:cNvSpPr txBox="1"/>
+          <p:nvPr/>
+        </p:nvSpPr>
+        <p:spPr>
+          <a:xfrm>
+            <a:off x="539496" y="2304796"/>
             <a:ext cx="6483096" cy="219456"/>
           </a:xfrm>
           <a:prstGeom prst="rect">
@@ -1340,13 +1446,13 @@
       </p:sp>
       <p:sp>
         <p:nvSpPr>
-          <p:cNvPr id="10" name="Text 6"/>
-          <p:cNvSpPr txBox="1"/>
-          <p:nvPr/>
-        </p:nvSpPr>
-        <p:spPr>
-          <a:xfrm>
-            <a:off x="539496" y="1872742"/>
+          <p:cNvPr id="13" name="Text 9"/>
+          <p:cNvSpPr txBox="1"/>
+          <p:nvPr/>
+        </p:nvSpPr>
+        <p:spPr>
+          <a:xfrm>
+            <a:off x="539496" y="2565400"/>
             <a:ext cx="576072" cy="156896"/>
           </a:xfrm>
           <a:prstGeom prst="rect">
@@ -1379,13 +1485,13 @@
       </p:sp>
       <p:sp>
         <p:nvSpPr>
-          <p:cNvPr id="11" name="Text 7"/>
-          <p:cNvSpPr txBox="1"/>
-          <p:nvPr/>
-        </p:nvSpPr>
-        <p:spPr>
-          <a:xfrm>
-            <a:off x="1133856" y="1849882"/>
+          <p:cNvPr id="14" name="Text 10"/>
+          <p:cNvSpPr txBox="1"/>
+          <p:nvPr/>
+        </p:nvSpPr>
+        <p:spPr>
+          <a:xfrm>
+            <a:off x="1133856" y="2542540"/>
             <a:ext cx="5888736" cy="156896"/>
           </a:xfrm>
           <a:prstGeom prst="rect">
@@ -1413,7 +1519,7 @@
                 <a:ea typeface="Nunito" pitchFamily="34" charset="-122"/>
                 <a:cs typeface="Nunito" pitchFamily="34" charset="-120"/>
               </a:rPr>
-              <a:t>Q3 revenue of EUR 9.0bn was in line; propulsion aftermarket rose 18.7% and defence beat.</a:t>
+              <a:t>Q3 revenue rose 13.4% organically to EUR 9.0bn; Q4 spare parts are guided up mid to high 20s.</a:t>
             </a:r>
             <a:endParaRPr lang="en-US" sz="870" dirty="0"/>
           </a:p>
@@ -1421,13 +1527,13 @@
       </p:sp>
       <p:sp>
         <p:nvSpPr>
-          <p:cNvPr id="12" name="Text 8"/>
-          <p:cNvSpPr txBox="1"/>
-          <p:nvPr/>
-        </p:nvSpPr>
-        <p:spPr>
-          <a:xfrm>
-            <a:off x="539496" y="2075358"/>
+          <p:cNvPr id="15" name="Text 11"/>
+          <p:cNvSpPr txBox="1"/>
+          <p:nvPr/>
+        </p:nvSpPr>
+        <p:spPr>
+          <a:xfrm>
+            <a:off x="539496" y="2768016"/>
             <a:ext cx="576072" cy="156896"/>
           </a:xfrm>
           <a:prstGeom prst="rect">
@@ -1460,13 +1566,13 @@
       </p:sp>
       <p:sp>
         <p:nvSpPr>
-          <p:cNvPr id="13" name="Text 9"/>
-          <p:cNvSpPr txBox="1"/>
-          <p:nvPr/>
-        </p:nvSpPr>
-        <p:spPr>
-          <a:xfrm>
-            <a:off x="1133856" y="2052498"/>
+          <p:cNvPr id="16" name="Text 12"/>
+          <p:cNvSpPr txBox="1"/>
+          <p:nvPr/>
+        </p:nvSpPr>
+        <p:spPr>
+          <a:xfrm>
+            <a:off x="1133856" y="2745156"/>
             <a:ext cx="5888736" cy="156896"/>
           </a:xfrm>
           <a:prstGeom prst="rect">
@@ -1494,7 +1600,7 @@
                 <a:ea typeface="Nunito" pitchFamily="34" charset="-122"/>
                 <a:cs typeface="Nunito" pitchFamily="34" charset="-120"/>
               </a:rPr>
-              <a:t>Targets were only confirmed: the EUR 6.45bn operating income midpoint sits 2.1% below consensus.</a:t>
+              <a:t>Targets were confirmed, not raised: the EUR 6.45bn operating income midpoint sits 2.1% below consensus.</a:t>
             </a:r>
             <a:endParaRPr lang="en-US" sz="870" dirty="0"/>
           </a:p>
@@ -1502,13 +1608,13 @@
       </p:sp>
       <p:sp>
         <p:nvSpPr>
-          <p:cNvPr id="14" name="Text 10"/>
-          <p:cNvSpPr txBox="1"/>
-          <p:nvPr/>
-        </p:nvSpPr>
-        <p:spPr>
-          <a:xfrm>
-            <a:off x="539496" y="2277974"/>
+          <p:cNvPr id="17" name="Text 13"/>
+          <p:cNvSpPr txBox="1"/>
+          <p:nvPr/>
+        </p:nvSpPr>
+        <p:spPr>
+          <a:xfrm>
+            <a:off x="539496" y="2970632"/>
             <a:ext cx="576072" cy="156896"/>
           </a:xfrm>
           <a:prstGeom prst="rect">
@@ -1541,13 +1647,13 @@
       </p:sp>
       <p:sp>
         <p:nvSpPr>
-          <p:cNvPr id="15" name="Text 11"/>
-          <p:cNvSpPr txBox="1"/>
-          <p:nvPr/>
-        </p:nvSpPr>
-        <p:spPr>
-          <a:xfrm>
-            <a:off x="1133856" y="2255114"/>
+          <p:cNvPr id="18" name="Text 14"/>
+          <p:cNvSpPr txBox="1"/>
+          <p:nvPr/>
+        </p:nvSpPr>
+        <p:spPr>
+          <a:xfrm>
+            <a:off x="1133856" y="2947772"/>
             <a:ext cx="5888736" cy="156896"/>
           </a:xfrm>
           <a:prstGeom prst="rect">
@@ -1575,7 +1681,7 @@
                 <a:ea typeface="Nunito" pitchFamily="34" charset="-122"/>
                 <a:cs typeface="Nunito" pitchFamily="34" charset="-120"/>
               </a:rPr>
-              <a:t>Jet fuel above $100 and a French surtax worth about EUR 500m this year cloud 2027.</a:t>
+              <a:t>2027 CFM56 aftermarket growth rests on price alone, while capex rises above 6% of sales.</a:t>
             </a:r>
             <a:endParaRPr lang="en-US" sz="870" dirty="0"/>
           </a:p>
@@ -1583,13 +1689,13 @@
       </p:sp>
       <p:sp>
         <p:nvSpPr>
-          <p:cNvPr id="16" name="Text 12"/>
-          <p:cNvSpPr txBox="1"/>
-          <p:nvPr/>
-        </p:nvSpPr>
-        <p:spPr>
-          <a:xfrm>
-            <a:off x="539496" y="2480589"/>
+          <p:cNvPr id="19" name="Text 15"/>
+          <p:cNvSpPr txBox="1"/>
+          <p:nvPr/>
+        </p:nvSpPr>
+        <p:spPr>
+          <a:xfrm>
+            <a:off x="539496" y="3173247"/>
             <a:ext cx="576072" cy="156896"/>
           </a:xfrm>
           <a:prstGeom prst="rect">
@@ -1622,13 +1728,13 @@
       </p:sp>
       <p:sp>
         <p:nvSpPr>
-          <p:cNvPr id="17" name="Text 13"/>
-          <p:cNvSpPr txBox="1"/>
-          <p:nvPr/>
-        </p:nvSpPr>
-        <p:spPr>
-          <a:xfrm>
-            <a:off x="1133856" y="2457729"/>
+          <p:cNvPr id="20" name="Text 16"/>
+          <p:cNvSpPr txBox="1"/>
+          <p:nvPr/>
+        </p:nvSpPr>
+        <p:spPr>
+          <a:xfrm>
+            <a:off x="1133856" y="3150387"/>
             <a:ext cx="5888736" cy="156896"/>
           </a:xfrm>
           <a:prstGeom prst="rect">
@@ -1664,13 +1770,13 @@
       </p:sp>
       <p:sp>
         <p:nvSpPr>
-          <p:cNvPr id="18" name="Shape 14"/>
+          <p:cNvPr id="21" name="Shape 17"/>
           <p:cNvSpPr/>
           <p:nvPr/>
         </p:nvSpPr>
         <p:spPr>
           <a:xfrm>
-            <a:off x="539496" y="2742641"/>
+            <a:off x="539496" y="3435299"/>
             <a:ext cx="6483096" cy="676656"/>
           </a:xfrm>
           <a:prstGeom prst="rect">
@@ -1689,13 +1795,13 @@
       </p:sp>
       <p:sp>
         <p:nvSpPr>
-          <p:cNvPr id="19" name="Text 15"/>
-          <p:cNvSpPr txBox="1"/>
-          <p:nvPr/>
-        </p:nvSpPr>
-        <p:spPr>
-          <a:xfrm>
-            <a:off x="649224" y="2824937"/>
+          <p:cNvPr id="22" name="Text 18"/>
+          <p:cNvSpPr txBox="1"/>
+          <p:nvPr/>
+        </p:nvSpPr>
+        <p:spPr>
+          <a:xfrm>
+            <a:off x="649224" y="3517595"/>
             <a:ext cx="1437894" cy="146304"/>
           </a:xfrm>
           <a:prstGeom prst="rect">
@@ -1728,13 +1834,13 @@
       </p:sp>
       <p:sp>
         <p:nvSpPr>
-          <p:cNvPr id="20" name="Text 16"/>
-          <p:cNvSpPr txBox="1"/>
-          <p:nvPr/>
-        </p:nvSpPr>
-        <p:spPr>
-          <a:xfrm>
-            <a:off x="649224" y="2971241"/>
+          <p:cNvPr id="23" name="Text 19"/>
+          <p:cNvSpPr txBox="1"/>
+          <p:nvPr/>
+        </p:nvSpPr>
+        <p:spPr>
+          <a:xfrm>
+            <a:off x="649224" y="3663899"/>
             <a:ext cx="1437894" cy="237744"/>
           </a:xfrm>
           <a:prstGeom prst="rect">
@@ -1767,13 +1873,13 @@
       </p:sp>
       <p:sp>
         <p:nvSpPr>
-          <p:cNvPr id="21" name="Text 17"/>
-          <p:cNvSpPr txBox="1"/>
-          <p:nvPr/>
-        </p:nvSpPr>
-        <p:spPr>
-          <a:xfrm>
-            <a:off x="649224" y="3208985"/>
+          <p:cNvPr id="24" name="Text 20"/>
+          <p:cNvSpPr txBox="1"/>
+          <p:nvPr/>
+        </p:nvSpPr>
+        <p:spPr>
+          <a:xfrm>
+            <a:off x="649224" y="3901643"/>
             <a:ext cx="1437894" cy="146304"/>
           </a:xfrm>
           <a:prstGeom prst="rect">
@@ -1806,13 +1912,13 @@
       </p:sp>
       <p:sp>
         <p:nvSpPr>
-          <p:cNvPr id="22" name="Shape 18"/>
+          <p:cNvPr id="25" name="Shape 21"/>
           <p:cNvSpPr/>
           <p:nvPr/>
         </p:nvSpPr>
         <p:spPr>
           <a:xfrm>
-            <a:off x="2160270" y="2742641"/>
+            <a:off x="2160270" y="3435299"/>
             <a:ext cx="0" cy="676656"/>
           </a:xfrm>
           <a:prstGeom prst="line">
@@ -1829,13 +1935,13 @@
       </p:sp>
       <p:sp>
         <p:nvSpPr>
-          <p:cNvPr id="23" name="Text 19"/>
-          <p:cNvSpPr txBox="1"/>
-          <p:nvPr/>
-        </p:nvSpPr>
-        <p:spPr>
-          <a:xfrm>
-            <a:off x="2269998" y="2824937"/>
+          <p:cNvPr id="26" name="Text 22"/>
+          <p:cNvSpPr txBox="1"/>
+          <p:nvPr/>
+        </p:nvSpPr>
+        <p:spPr>
+          <a:xfrm>
+            <a:off x="2269998" y="3517595"/>
             <a:ext cx="1437894" cy="146304"/>
           </a:xfrm>
           <a:prstGeom prst="rect">
@@ -1860,7 +1966,7 @@
                 <a:ea typeface="Nunito" pitchFamily="34" charset="-122"/>
                 <a:cs typeface="Nunito" pitchFamily="34" charset="-120"/>
               </a:rPr>
-              <a:t>Propulsion aftermarket</a:t>
+              <a:t>Civil spare parts (USD)</a:t>
             </a:r>
             <a:endParaRPr lang="en-US" sz="720" dirty="0"/>
           </a:p>
@@ -1868,13 +1974,13 @@
       </p:sp>
       <p:sp>
         <p:nvSpPr>
-          <p:cNvPr id="24" name="Text 20"/>
-          <p:cNvSpPr txBox="1"/>
-          <p:nvPr/>
-        </p:nvSpPr>
-        <p:spPr>
-          <a:xfrm>
-            <a:off x="2269998" y="2971241"/>
+          <p:cNvPr id="27" name="Text 23"/>
+          <p:cNvSpPr txBox="1"/>
+          <p:nvPr/>
+        </p:nvSpPr>
+        <p:spPr>
+          <a:xfrm>
+            <a:off x="2269998" y="3663899"/>
             <a:ext cx="1437894" cy="237744"/>
           </a:xfrm>
           <a:prstGeom prst="rect">
@@ -1899,7 +2005,7 @@
                 <a:ea typeface="Nunito" pitchFamily="34" charset="-122"/>
                 <a:cs typeface="Nunito" pitchFamily="34" charset="-120"/>
               </a:rPr>
-              <a:t>+18.7%</a:t>
+              <a:t>+17%</a:t>
             </a:r>
             <a:endParaRPr lang="en-US" sz="1300" dirty="0"/>
           </a:p>
@@ -1907,13 +2013,13 @@
       </p:sp>
       <p:sp>
         <p:nvSpPr>
-          <p:cNvPr id="25" name="Text 21"/>
-          <p:cNvSpPr txBox="1"/>
-          <p:nvPr/>
-        </p:nvSpPr>
-        <p:spPr>
-          <a:xfrm>
-            <a:off x="2269998" y="3208985"/>
+          <p:cNvPr id="28" name="Text 24"/>
+          <p:cNvSpPr txBox="1"/>
+          <p:nvPr/>
+        </p:nvSpPr>
+        <p:spPr>
+          <a:xfrm>
+            <a:off x="2269998" y="3901643"/>
             <a:ext cx="1437894" cy="146304"/>
           </a:xfrm>
           <a:prstGeom prst="rect">
@@ -1938,7 +2044,7 @@
                 <a:ea typeface="Nunito" pitchFamily="34" charset="-122"/>
                 <a:cs typeface="Nunito" pitchFamily="34" charset="-120"/>
               </a:rPr>
-              <a:t>Original equipment +3.5%</a:t>
+              <a:t>Q4 guided mid to high 20s</a:t>
             </a:r>
             <a:endParaRPr lang="en-US" sz="720" dirty="0"/>
           </a:p>
@@ -1946,13 +2052,13 @@
       </p:sp>
       <p:sp>
         <p:nvSpPr>
-          <p:cNvPr id="26" name="Shape 22"/>
+          <p:cNvPr id="29" name="Shape 25"/>
           <p:cNvSpPr/>
           <p:nvPr/>
         </p:nvSpPr>
         <p:spPr>
           <a:xfrm>
-            <a:off x="3781044" y="2742641"/>
+            <a:off x="3781044" y="3435299"/>
             <a:ext cx="0" cy="676656"/>
           </a:xfrm>
           <a:prstGeom prst="line">
@@ -1969,13 +2075,13 @@
       </p:sp>
       <p:sp>
         <p:nvSpPr>
-          <p:cNvPr id="27" name="Text 23"/>
-          <p:cNvSpPr txBox="1"/>
-          <p:nvPr/>
-        </p:nvSpPr>
-        <p:spPr>
-          <a:xfrm>
-            <a:off x="3890772" y="2824937"/>
+          <p:cNvPr id="30" name="Text 26"/>
+          <p:cNvSpPr txBox="1"/>
+          <p:nvPr/>
+        </p:nvSpPr>
+        <p:spPr>
+          <a:xfrm>
+            <a:off x="3890772" y="3517595"/>
             <a:ext cx="1437894" cy="146304"/>
           </a:xfrm>
           <a:prstGeom prst="rect">
@@ -2000,7 +2106,7 @@
                 <a:ea typeface="Nunito" pitchFamily="34" charset="-122"/>
                 <a:cs typeface="Nunito" pitchFamily="34" charset="-120"/>
               </a:rPr>
-              <a:t>LEAP deliveries</a:t>
+              <a:t>LEAP deliveries, 9 months</a:t>
             </a:r>
             <a:endParaRPr lang="en-US" sz="720" dirty="0"/>
           </a:p>
@@ -2008,13 +2114,13 @@
       </p:sp>
       <p:sp>
         <p:nvSpPr>
-          <p:cNvPr id="28" name="Text 24"/>
-          <p:cNvSpPr txBox="1"/>
-          <p:nvPr/>
-        </p:nvSpPr>
-        <p:spPr>
-          <a:xfrm>
-            <a:off x="3890772" y="2971241"/>
+          <p:cNvPr id="31" name="Text 27"/>
+          <p:cNvSpPr txBox="1"/>
+          <p:nvPr/>
+        </p:nvSpPr>
+        <p:spPr>
+          <a:xfrm>
+            <a:off x="3890772" y="3663899"/>
             <a:ext cx="1437894" cy="237744"/>
           </a:xfrm>
           <a:prstGeom prst="rect">
@@ -2039,7 +2145,7 @@
                 <a:ea typeface="Nunito" pitchFamily="34" charset="-122"/>
                 <a:cs typeface="Nunito" pitchFamily="34" charset="-120"/>
               </a:rPr>
-              <a:t>535</a:t>
+              <a:t>1,565</a:t>
             </a:r>
             <a:endParaRPr lang="en-US" sz="1300" dirty="0"/>
           </a:p>
@@ -2047,13 +2153,13 @@
       </p:sp>
       <p:sp>
         <p:nvSpPr>
-          <p:cNvPr id="29" name="Text 25"/>
-          <p:cNvSpPr txBox="1"/>
-          <p:nvPr/>
-        </p:nvSpPr>
-        <p:spPr>
-          <a:xfrm>
-            <a:off x="3890772" y="3208985"/>
+          <p:cNvPr id="32" name="Text 28"/>
+          <p:cNvSpPr txBox="1"/>
+          <p:nvPr/>
+        </p:nvSpPr>
+        <p:spPr>
+          <a:xfrm>
+            <a:off x="3890772" y="3901643"/>
             <a:ext cx="1437894" cy="146304"/>
           </a:xfrm>
           <a:prstGeom prst="rect">
@@ -2078,7 +2184,7 @@
                 <a:ea typeface="Nunito" pitchFamily="34" charset="-122"/>
                 <a:cs typeface="Nunito" pitchFamily="34" charset="-120"/>
               </a:rPr>
-              <a:t>+5% y/y</a:t>
+              <a:t>+26% y/y, FY above 2,100</a:t>
             </a:r>
             <a:endParaRPr lang="en-US" sz="720" dirty="0"/>
           </a:p>
@@ -2086,13 +2192,13 @@
       </p:sp>
       <p:sp>
         <p:nvSpPr>
-          <p:cNvPr id="30" name="Shape 26"/>
+          <p:cNvPr id="33" name="Shape 29"/>
           <p:cNvSpPr/>
           <p:nvPr/>
         </p:nvSpPr>
         <p:spPr>
           <a:xfrm>
-            <a:off x="5401818" y="2742641"/>
+            <a:off x="5401818" y="3435299"/>
             <a:ext cx="0" cy="676656"/>
           </a:xfrm>
           <a:prstGeom prst="line">
@@ -2109,13 +2215,13 @@
       </p:sp>
       <p:sp>
         <p:nvSpPr>
-          <p:cNvPr id="31" name="Text 27"/>
-          <p:cNvSpPr txBox="1"/>
-          <p:nvPr/>
-        </p:nvSpPr>
-        <p:spPr>
-          <a:xfrm>
-            <a:off x="5511546" y="2824937"/>
+          <p:cNvPr id="34" name="Text 30"/>
+          <p:cNvSpPr txBox="1"/>
+          <p:nvPr/>
+        </p:nvSpPr>
+        <p:spPr>
+          <a:xfrm>
+            <a:off x="5511546" y="3517595"/>
             <a:ext cx="1437894" cy="146304"/>
           </a:xfrm>
           <a:prstGeom prst="rect">
@@ -2148,13 +2254,13 @@
       </p:sp>
       <p:sp>
         <p:nvSpPr>
-          <p:cNvPr id="32" name="Text 28"/>
-          <p:cNvSpPr txBox="1"/>
-          <p:nvPr/>
-        </p:nvSpPr>
-        <p:spPr>
-          <a:xfrm>
-            <a:off x="5511546" y="2971241"/>
+          <p:cNvPr id="35" name="Text 31"/>
+          <p:cNvSpPr txBox="1"/>
+          <p:nvPr/>
+        </p:nvSpPr>
+        <p:spPr>
+          <a:xfrm>
+            <a:off x="5511546" y="3663899"/>
             <a:ext cx="1437894" cy="237744"/>
           </a:xfrm>
           <a:prstGeom prst="rect">
@@ -2187,13 +2293,13 @@
       </p:sp>
       <p:sp>
         <p:nvSpPr>
-          <p:cNvPr id="33" name="Text 29"/>
-          <p:cNvSpPr txBox="1"/>
-          <p:nvPr/>
-        </p:nvSpPr>
-        <p:spPr>
-          <a:xfrm>
-            <a:off x="5511546" y="3208985"/>
+          <p:cNvPr id="36" name="Text 32"/>
+          <p:cNvSpPr txBox="1"/>
+          <p:nvPr/>
+        </p:nvSpPr>
+        <p:spPr>
+          <a:xfrm>
+            <a:off x="5511546" y="3901643"/>
             <a:ext cx="1437894" cy="146304"/>
           </a:xfrm>
           <a:prstGeom prst="rect">
@@ -2226,13 +2332,13 @@
       </p:sp>
       <p:sp>
         <p:nvSpPr>
-          <p:cNvPr id="34" name="Text 30"/>
-          <p:cNvSpPr txBox="1"/>
-          <p:nvPr/>
-        </p:nvSpPr>
-        <p:spPr>
-          <a:xfrm>
-            <a:off x="539496" y="3538169"/>
+          <p:cNvPr id="37" name="Text 33"/>
+          <p:cNvSpPr txBox="1"/>
+          <p:nvPr/>
+        </p:nvSpPr>
+        <p:spPr>
+          <a:xfrm>
+            <a:off x="539496" y="4230827"/>
             <a:ext cx="6483096" cy="219456"/>
           </a:xfrm>
           <a:prstGeom prst="rect">
@@ -2265,14 +2371,14 @@
       </p:sp>
       <p:sp>
         <p:nvSpPr>
-          <p:cNvPr id="35" name="Text 31"/>
-          <p:cNvSpPr txBox="1"/>
-          <p:nvPr/>
-        </p:nvSpPr>
-        <p:spPr>
-          <a:xfrm>
-            <a:off x="539496" y="3785057"/>
-            <a:ext cx="6483096" cy="802767"/>
+          <p:cNvPr id="38" name="Text 34"/>
+          <p:cNvSpPr txBox="1"/>
+          <p:nvPr/>
+        </p:nvSpPr>
+        <p:spPr>
+          <a:xfrm>
+            <a:off x="539496" y="4477715"/>
+            <a:ext cx="6483096" cy="645871"/>
           </a:xfrm>
           <a:prstGeom prst="rect">
             <a:avLst/>
@@ -2299,7 +2405,7 @@
                 <a:ea typeface="Nunito" pitchFamily="34" charset="-122"/>
                 <a:cs typeface="Nunito" pitchFamily="34" charset="-120"/>
               </a:rPr>
-              <a:t>The quarter itself was sound: revenue matched consensus, the engine aftermarket kept growing close to 20% and defence equipment beat. What disappointed was the absence of a second guidance upgrade after July’s raise, with operating income held at EUR 6.4bn to EUR 6.5bn while consensus already sat above the range. With jet fuel above $100, a French surtax likely to be extended and a cautious read-across from GE, investors now question how long airlines keep spending heavily on engine maintenance.</a:t>
+              <a:t>The quarter was sound, and the 2026 targets held even though a LEAP-1B maintenance-contract profit release in the low hundreds of millions of euros slipped into 2027. Investors wanted more: no upgrade, a CFM56 aftermarket that grows only through price in 2027, capital spending stepping up to above 6% of sales and a French surtax extended into 2027. Management answered the fear of shrinking workscopes directly: they should stay at today’s high level.</a:t>
             </a:r>
             <a:endParaRPr lang="en-US" sz="870" dirty="0"/>
           </a:p>
@@ -2307,13 +2413,13 @@
       </p:sp>
       <p:sp>
         <p:nvSpPr>
-          <p:cNvPr id="36" name="Text 32"/>
-          <p:cNvSpPr txBox="1"/>
-          <p:nvPr/>
-        </p:nvSpPr>
-        <p:spPr>
-          <a:xfrm>
-            <a:off x="539496" y="4667377"/>
+          <p:cNvPr id="39" name="Text 35"/>
+          <p:cNvSpPr txBox="1"/>
+          <p:nvPr/>
+        </p:nvSpPr>
+        <p:spPr>
+          <a:xfrm>
+            <a:off x="539496" y="5203139"/>
             <a:ext cx="6483096" cy="182880"/>
           </a:xfrm>
           <a:prstGeom prst="rect">
@@ -2360,13 +2466,13 @@
       </p:sp>
       <p:sp>
         <p:nvSpPr>
-          <p:cNvPr id="37" name="Text 33"/>
-          <p:cNvSpPr txBox="1"/>
-          <p:nvPr/>
-        </p:nvSpPr>
-        <p:spPr>
-          <a:xfrm>
-            <a:off x="539496" y="4850257"/>
+          <p:cNvPr id="40" name="Text 36"/>
+          <p:cNvSpPr txBox="1"/>
+          <p:nvPr/>
+        </p:nvSpPr>
+        <p:spPr>
+          <a:xfrm>
+            <a:off x="539496" y="5386019"/>
             <a:ext cx="6483096" cy="118872"/>
           </a:xfrm>
           <a:prstGeom prst="rect">
@@ -2402,7 +2508,7 @@
       </p:sp>
       <p:pic>
         <p:nvPicPr>
-          <p:cNvPr id="38" name="Image 2" descr="/home/claude/saf/c1_crop.png">    </p:cNvPr>
+          <p:cNvPr id="41" name="Image 2" descr="/home/claude/saf/c1_crop.png">    </p:cNvPr>
           <p:cNvPicPr>
             <a:picLocks noChangeAspect="1"/>
           </p:cNvPicPr>
@@ -2416,8 +2522,8 @@
         </p:blipFill>
         <p:spPr>
           <a:xfrm>
-            <a:off x="1511960" y="5014849"/>
-            <a:ext cx="4538167" cy="1415908"/>
+            <a:off x="1641622" y="5550611"/>
+            <a:ext cx="4278843" cy="1334999"/>
           </a:xfrm>
           <a:prstGeom prst="rect">
             <a:avLst/>
@@ -2426,13 +2532,13 @@
       </p:pic>
       <p:sp>
         <p:nvSpPr>
-          <p:cNvPr id="39" name="Text 34"/>
-          <p:cNvSpPr txBox="1"/>
-          <p:nvPr/>
-        </p:nvSpPr>
-        <p:spPr>
-          <a:xfrm>
-            <a:off x="539496" y="6485621"/>
+          <p:cNvPr id="42" name="Text 37"/>
+          <p:cNvSpPr txBox="1"/>
+          <p:nvPr/>
+        </p:nvSpPr>
+        <p:spPr>
+          <a:xfrm>
+            <a:off x="539496" y="6940474"/>
             <a:ext cx="6483096" cy="645871"/>
           </a:xfrm>
           <a:prstGeom prst="rect">
@@ -2460,7 +2566,7 @@
                 <a:ea typeface="Nunito" pitchFamily="34" charset="-122"/>
                 <a:cs typeface="Nunito" pitchFamily="34" charset="-120"/>
               </a:rPr>
-              <a:t>The reported lines were in line or better: group revenue matched the company-compiled consensus within 0.1% and Equipment &amp; Defense beat by 2.5%. Aircraft Interiors missed by 1.3%, as seat certification delays flagged in July persist. The two bars on the right carry the message: confirmed targets sit about 2% below consensus, so estimates edge down rather than up into the full-year results.</a:t>
+              <a:t>Group revenue matched the company-compiled consensus within 0.1% and Equipment &amp; Defense beat by 2.5% on guided bombs, optronics, navigation and missile seekers. Aircraft Interiors missed by 1.3%, as seat certification still paces deliveries. The two bars on the right carry the message: confirmed targets sit about 2% below consensus, so estimates edge down rather than up into the full-year results.</a:t>
             </a:r>
             <a:endParaRPr lang="en-US" sz="870" dirty="0"/>
           </a:p>
@@ -2468,13 +2574,13 @@
       </p:sp>
       <p:sp>
         <p:nvSpPr>
-          <p:cNvPr id="40" name="Text 35"/>
-          <p:cNvSpPr txBox="1"/>
-          <p:nvPr/>
-        </p:nvSpPr>
-        <p:spPr>
-          <a:xfrm>
-            <a:off x="539496" y="7247621"/>
+          <p:cNvPr id="43" name="Text 38"/>
+          <p:cNvSpPr txBox="1"/>
+          <p:nvPr/>
+        </p:nvSpPr>
+        <p:spPr>
+          <a:xfrm>
+            <a:off x="539496" y="7702474"/>
             <a:ext cx="6483096" cy="219456"/>
           </a:xfrm>
           <a:prstGeom prst="rect">
@@ -2507,14 +2613,14 @@
       </p:sp>
       <p:sp>
         <p:nvSpPr>
-          <p:cNvPr id="41" name="Text 36"/>
-          <p:cNvSpPr txBox="1"/>
-          <p:nvPr/>
-        </p:nvSpPr>
-        <p:spPr>
-          <a:xfrm>
-            <a:off x="539496" y="7494509"/>
-            <a:ext cx="6483096" cy="959663"/>
+          <p:cNvPr id="44" name="Text 39"/>
+          <p:cNvSpPr txBox="1"/>
+          <p:nvPr/>
+        </p:nvSpPr>
+        <p:spPr>
+          <a:xfrm>
+            <a:off x="539496" y="7949362"/>
+            <a:ext cx="6483096" cy="802767"/>
           </a:xfrm>
           <a:prstGeom prst="rect">
             <a:avLst/>
@@ -2541,7 +2647,7 @@
                 <a:ea typeface="Nunito" pitchFamily="34" charset="-122"/>
                 <a:cs typeface="Nunito" pitchFamily="34" charset="-120"/>
               </a:rPr>
-              <a:t>We stay positive on Safran and would build positions on this weakness. The earnings path we underwrite is intact: 2026 operating income of EUR 6.4bn to EUR 6.5bn, a 2028 target of EUR 7bn to EUR 7.5bn that management said in July may be revisited, and profits on LEAP-1B maintenance contracts recognised from early 2027, which moves earnings into next year rather than removing them. The debate has moved from engine deliveries to the durability of heavy maintenance spending. The catalyst is 2027 guidance at the full-year results in February 2027. Near term, jet fuel and French tax headlines can keep the shares under pressure.</a:t>
+              <a:t>We stay positive on Safran and would build positions on this weakness. The earnings path we underwrite is intact: 2026 operating income of EUR 6.4bn to EUR 6.5bn reached without the LEAP-1B profit release, which now adds to 2027, and a 2028 target of EUR 7bn to EUR 7.5bn that management said in July may be revisited. The debate has moved to 2027 aftermarket growth, now framed as CFM56 price plus LEAP volume. The catalyst is 2027 guidance at the full-year results in February. Near term, jet fuel and French tax headlines can keep the shares under pressure.</a:t>
             </a:r>
             <a:endParaRPr lang="en-US" sz="870" dirty="0"/>
           </a:p>
@@ -2549,13 +2655,13 @@
       </p:sp>
       <p:sp>
         <p:nvSpPr>
-          <p:cNvPr id="42" name="Shape 37"/>
+          <p:cNvPr id="45" name="Shape 40"/>
           <p:cNvSpPr/>
           <p:nvPr/>
         </p:nvSpPr>
         <p:spPr>
           <a:xfrm>
-            <a:off x="3781044" y="8570301"/>
+            <a:off x="3781044" y="8868258"/>
             <a:ext cx="0" cy="985647"/>
           </a:xfrm>
           <a:prstGeom prst="line">
@@ -2572,13 +2678,13 @@
       </p:sp>
       <p:sp>
         <p:nvSpPr>
-          <p:cNvPr id="43" name="Text 38"/>
-          <p:cNvSpPr txBox="1"/>
-          <p:nvPr/>
-        </p:nvSpPr>
-        <p:spPr>
-          <a:xfrm>
-            <a:off x="539496" y="8570301"/>
+          <p:cNvPr id="46" name="Text 41"/>
+          <p:cNvSpPr txBox="1"/>
+          <p:nvPr/>
+        </p:nvSpPr>
+        <p:spPr>
+          <a:xfrm>
+            <a:off x="539496" y="8868258"/>
             <a:ext cx="3058668" cy="155448"/>
           </a:xfrm>
           <a:prstGeom prst="rect">
@@ -2611,13 +2717,13 @@
       </p:sp>
       <p:sp>
         <p:nvSpPr>
-          <p:cNvPr id="44" name="Text 39"/>
-          <p:cNvSpPr txBox="1"/>
-          <p:nvPr/>
-        </p:nvSpPr>
-        <p:spPr>
-          <a:xfrm>
-            <a:off x="539496" y="8762325"/>
+          <p:cNvPr id="47" name="Text 42"/>
+          <p:cNvSpPr txBox="1"/>
+          <p:nvPr/>
+        </p:nvSpPr>
+        <p:spPr>
+          <a:xfrm>
+            <a:off x="539496" y="9060282"/>
             <a:ext cx="3058668" cy="784479"/>
           </a:xfrm>
           <a:prstGeom prst="rect">
@@ -2645,7 +2751,7 @@
                 <a:ea typeface="Nunito" pitchFamily="34" charset="-122"/>
                 <a:cs typeface="Nunito" pitchFamily="34" charset="-120"/>
               </a:rPr>
-              <a:t>2027 guidance in February implying operating income growth above 10%; heavy CFM56 shop visits holding, as management expected in July; advance payments on India’s 114 Rafale order, which are not in guidance; LEAP deliveries reaching high-teens growth for 2026.</a:t>
+              <a:t>2027 guidance in February implying operating income growth above 10%, helped by the LEAP-1B profit release; Q4 spare parts up in the mid to high 20s as guided; advance payments on India’s 114 Rafale order; a good price for the cabin business.</a:t>
             </a:r>
             <a:endParaRPr lang="en-US" sz="870" dirty="0"/>
           </a:p>
@@ -2653,13 +2759,13 @@
       </p:sp>
       <p:sp>
         <p:nvSpPr>
-          <p:cNvPr id="45" name="Text 40"/>
-          <p:cNvSpPr txBox="1"/>
-          <p:nvPr/>
-        </p:nvSpPr>
-        <p:spPr>
-          <a:xfrm>
-            <a:off x="3963924" y="8570301"/>
+          <p:cNvPr id="48" name="Text 43"/>
+          <p:cNvSpPr txBox="1"/>
+          <p:nvPr/>
+        </p:nvSpPr>
+        <p:spPr>
+          <a:xfrm>
+            <a:off x="3963924" y="8868258"/>
             <a:ext cx="3058668" cy="155448"/>
           </a:xfrm>
           <a:prstGeom prst="rect">
@@ -2692,13 +2798,13 @@
       </p:sp>
       <p:sp>
         <p:nvSpPr>
-          <p:cNvPr id="46" name="Text 41"/>
-          <p:cNvSpPr txBox="1"/>
-          <p:nvPr/>
-        </p:nvSpPr>
-        <p:spPr>
-          <a:xfrm>
-            <a:off x="3963924" y="8762325"/>
+          <p:cNvPr id="49" name="Text 44"/>
+          <p:cNvSpPr txBox="1"/>
+          <p:nvPr/>
+        </p:nvSpPr>
+        <p:spPr>
+          <a:xfrm>
+            <a:off x="3963924" y="9060282"/>
             <a:ext cx="3058668" cy="784479"/>
           </a:xfrm>
           <a:prstGeom prst="rect">
@@ -2726,7 +2832,7 @@
                 <a:ea typeface="Nunito" pitchFamily="34" charset="-122"/>
                 <a:cs typeface="Nunito" pitchFamily="34" charset="-120"/>
               </a:rPr>
-              <a:t>Evidence of workscope compression, with airlines deferring heavy CFM56 shop visits while jet fuel stays above $100; the French surtax extended into 2027 at the 2026 level; LEAP delivery growth short of the high-teens target, pointing to supply-chain strain.</a:t>
+              <a:t>CFM56 retirements running above the 3% baseline assumed for 2027, or shop visits falling below the 2,400 plateau; the French surtax kept at the 2026 rate, worth EUR 500m or more in 2027; capex above 6% of sales eroding cash conversion.</a:t>
             </a:r>
             <a:endParaRPr lang="en-US" sz="870" dirty="0"/>
           </a:p>
@@ -3004,7 +3110,7 @@
                 <a:ea typeface="Nunito" pitchFamily="34" charset="-122"/>
                 <a:cs typeface="Nunito" pitchFamily="34" charset="-120"/>
               </a:rPr>
-              <a:t>Revenue reached EUR 9.0bn, up 14.7% reported and 13.4% organically, in line with the EUR 8.99bn company-compiled consensus. Propulsion grew 13.2% organically. The mix remains the story: aftermarket revenue rose 18.7% and services 19.0% in dollars, while original equipment grew only 3.5%. LEAP deliveries reached 535 engines, up 5%, a sharp slowdown after 41% growth in the first half, which leaves a heavy fourth quarter to meet the high-teens target for the year. Aftermarket-led growth is good for profit: in the first half it lifted the propulsion margin to a record 24.5%, above the 22% to 24% range, and the group margin to 18.4%.</a:t>
+              <a:t>Revenue reached EUR 9.0bn, up 14.7% reported and 13.4% organically, in line with the EUR 8.99bn company-compiled consensus; currency added 1.1 points and scope was neutral. Propulsion revenue rose 13% organically to EUR 4.6bn. Civil engine spare parts grew 17% in dollars, below the 24% over nine months because of a strong Q3 2025 base, but up 4% on the second quarter, helped by CFM56 and LEAP pricing. Services grew 19%, led by LEAP maintenance contracts, while military engines declined on the Rafale delivery schedule. LEAP deliveries reached 535, up 5%, and 1,565 over nine months, up 26%, on track for more than 2,100 this year.</a:t>
             </a:r>
             <a:endParaRPr lang="en-US" sz="870" dirty="0"/>
           </a:p>
@@ -3019,7 +3125,7 @@
         <p:spPr>
           <a:xfrm>
             <a:off x="539496" y="2470252"/>
-            <a:ext cx="6483096" cy="802767"/>
+            <a:ext cx="6483096" cy="959663"/>
           </a:xfrm>
           <a:prstGeom prst="rect">
             <a:avLst/>
@@ -3046,7 +3152,7 @@
                 <a:ea typeface="Nunito" pitchFamily="34" charset="-122"/>
                 <a:cs typeface="Nunito" pitchFamily="34" charset="-120"/>
               </a:rPr>
-              <a:t>Equipment &amp; Defense revenue rose 16% organically to EUR 3.62bn, against EUR 3.53bn expected, the strongest division in the quarter. Reported growth is flattered by the integration of the Collins actuation business and by the transfer of Safran Ventilation Systems from Aircraft Interiors at the start of 2026. Aircraft Interiors grew 6% organically to EUR 751m, against EUR 761m expected; seat deliveries remain capped by certification delays that management in July called an industry issue. Safran reports no profit figures at the third quarter, so the margin read waits for February.</a:t>
+              <a:t>Equipment &amp; Defense revenue rose 16% organically to EUR 3.6bn, ahead of the EUR 3.53bn expected, on strong demand for Hammer guided bombs, optronics, inertial navigation and missile seekers. Aircraft Interiors grew 6% to EUR 751m, against EUR 761m expected; certification still paces seat deliveries and may push some into early 2027. Safran has launched the sale of its cabin business, about EUR 2bn of revenue with positive operating profit and cash flow. Airbus selected the SkyNaute inertial navigation system for the A220, Safran’s entry into commercial navigation. No profit figures are reported at the third quarter.</a:t>
             </a:r>
             <a:endParaRPr lang="en-US" sz="870" dirty="0"/>
           </a:p>
@@ -3060,7 +3166,7 @@
         </p:nvSpPr>
         <p:spPr>
           <a:xfrm>
-            <a:off x="539496" y="3389147"/>
+            <a:off x="539496" y="3546043"/>
             <a:ext cx="6483096" cy="219456"/>
           </a:xfrm>
           <a:prstGeom prst="rect">
@@ -3085,7 +3191,7 @@
                 <a:ea typeface="Nunito" pitchFamily="34" charset="-122"/>
                 <a:cs typeface="Nunito" pitchFamily="34" charset="-120"/>
               </a:rPr>
-              <a:t>Outlook: guidance held, upside pushed to 2027</a:t>
+              <a:t>Outlook: 2026 held, 2027 rests on price and LEAP</a:t>
             </a:r>
             <a:endParaRPr lang="en-US" sz="1100" dirty="0"/>
           </a:p>
@@ -3099,7 +3205,7 @@
         </p:nvSpPr>
         <p:spPr>
           <a:xfrm>
-            <a:off x="539496" y="3636035"/>
+            <a:off x="539496" y="3792931"/>
             <a:ext cx="6483096" cy="802767"/>
           </a:xfrm>
           <a:prstGeom prst="rect">
@@ -3127,7 +3233,7 @@
                 <a:ea typeface="Nunito" pitchFamily="34" charset="-122"/>
                 <a:cs typeface="Nunito" pitchFamily="34" charset="-120"/>
               </a:rPr>
-              <a:t>Safran confirmed the 2026 targets raised in July: revenue growth in the mid-teens, recurring operating income of EUR 6.4bn to EUR 6.5bn and free cash flow of EUR 4.7bn to EUR 4.9bn, including about EUR 500m of French surtax. The midpoints sit 2.1% and 1.8% below consensus, so estimates should drift lower. Profit recognition on LEAP-1B maintenance contracts is now expected in early 2027 rather than late 2026: a timing shift that removes a 2026 upside and adds to 2027. In July, management expected heavy CFM56 workscopes to last through 2027 and 2028.</a:t>
+              <a:t>Safran confirmed its 2026 targets: revenue growth in the mid-teens, recurring operating income of EUR 6.4bn to EUR 6.5bn and free cash flow of EUR 4.7bn to EUR 4.9bn, despite moving a LEAP-1B profit release in the low hundreds of millions of euros to 2027. Spare parts should rise by the mid to high 20s in Q4 and the mid-20s for the year. For 2027, management expects CFM56 shop visits flat at 2,400 and workscopes stable at today’s high level, so growth comes from price and LEAP. Capex will exceed 6% of sales every year, and the draft 2027 budget extends the surtax, at a cost of around EUR 400m.</a:t>
             </a:r>
             <a:endParaRPr lang="en-US" sz="870" dirty="0"/>
           </a:p>
@@ -3141,7 +3247,7 @@
         </p:nvSpPr>
         <p:spPr>
           <a:xfrm>
-            <a:off x="539496" y="4554931"/>
+            <a:off x="539496" y="4711827"/>
             <a:ext cx="6483096" cy="219456"/>
           </a:xfrm>
           <a:prstGeom prst="rect">
@@ -3180,7 +3286,7 @@
         </p:nvSpPr>
         <p:spPr>
           <a:xfrm>
-            <a:off x="539496" y="4801819"/>
+            <a:off x="539496" y="4958715"/>
             <a:ext cx="6483096" cy="182880"/>
           </a:xfrm>
           <a:prstGeom prst="rect">
@@ -3233,7 +3339,7 @@
         </p:nvSpPr>
         <p:spPr>
           <a:xfrm>
-            <a:off x="539496" y="4984699"/>
+            <a:off x="539496" y="5141595"/>
             <a:ext cx="6483096" cy="118872"/>
           </a:xfrm>
           <a:prstGeom prst="rect">
@@ -3283,7 +3389,7 @@
         </p:blipFill>
         <p:spPr>
           <a:xfrm>
-            <a:off x="928482" y="5149291"/>
+            <a:off x="928482" y="5306187"/>
             <a:ext cx="5705124" cy="3413946"/>
           </a:xfrm>
           <a:prstGeom prst="rect">
@@ -3299,7 +3405,7 @@
         </p:nvSpPr>
         <p:spPr>
           <a:xfrm>
-            <a:off x="539496" y="8618102"/>
+            <a:off x="539496" y="8774997"/>
             <a:ext cx="6483096" cy="802767"/>
           </a:xfrm>
           <a:prstGeom prst="rect">
@@ -3538,7 +3644,7 @@
                 <a:ea typeface="Nunito" pitchFamily="34" charset="-122"/>
                 <a:cs typeface="Nunito" pitchFamily="34" charset="-120"/>
               </a:rPr>
-              <a:t> Source: Syz Research, Bloomberg, Safran Q3 2026 revenue release of 23 October 2026, Safran H1 2026 earnings call of 28 July 2026, analyst research notes of 23 October 2026</a:t>
+              <a:t> Source: Syz Research, Bloomberg, Safran Q3 2026 revenue call of 23 October 2026, Safran H1 2026 earnings call of 28 July 2026, company-compiled consensus, analyst research notes of 23 October 2026</a:t>
             </a:r>
             <a:endParaRPr lang="en-US" sz="680" dirty="0"/>
           </a:p>

</xml_diff>

<commit_message>
SAF Q3 2026: new title, reflect the no-upgrade and macro-headwind read
Co-Authored-By: Claude Opus 5.5 <noreply@anthropic.com>
Claude-Session: https://claude.ai/code/session_014d3kFaWCeVNznnbSptWmJY
</commit_message>
<xml_diff>
--- a/reports/SAF_Q3_2026/Earnings_Update_SAF_Q32026.pptx
+++ b/reports/SAF_Q3_2026/Earnings_Update_SAF_Q32026.pptx
@@ -1254,7 +1254,7 @@
                 <a:ea typeface="Nunito" pitchFamily="34" charset="-122"/>
                 <a:cs typeface="Nunito" pitchFamily="34" charset="-120"/>
               </a:rPr>
-              <a:t>Safran Q3 2026: no upgrade, the de-rating overshoots</a:t>
+              <a:t>Safran Q3 2026: a solid engine, no fuel for upgrades</a:t>
             </a:r>
             <a:endParaRPr lang="en-US" sz="1700" dirty="0"/>
           </a:p>
@@ -1477,7 +1477,7 @@
                 <a:ea typeface="Nunito" pitchFamily="34" charset="-122"/>
                 <a:cs typeface="Nunito" pitchFamily="34" charset="-120"/>
               </a:rPr>
-              <a:t>In line</a:t>
+              <a:t>Solid</a:t>
             </a:r>
             <a:endParaRPr lang="en-US" sz="700" dirty="0"/>
           </a:p>
@@ -1519,7 +1519,7 @@
                 <a:ea typeface="Nunito" pitchFamily="34" charset="-122"/>
                 <a:cs typeface="Nunito" pitchFamily="34" charset="-120"/>
               </a:rPr>
-              <a:t>Q3 revenue rose 13.4% organically to EUR 9.0bn; Q4 spare parts are guided up mid to high 20s.</a:t>
+              <a:t>Revenue of EUR 9.0bn was in line and civil spare parts rose 17%: the aftermarket holds.</a:t>
             </a:r>
             <a:endParaRPr lang="en-US" sz="870" dirty="0"/>
           </a:p>
@@ -1600,7 +1600,7 @@
                 <a:ea typeface="Nunito" pitchFamily="34" charset="-122"/>
                 <a:cs typeface="Nunito" pitchFamily="34" charset="-120"/>
               </a:rPr>
-              <a:t>Targets were confirmed, not raised: the EUR 6.45bn operating income midpoint sits 2.1% below consensus.</a:t>
+              <a:t>Unchanged targets offer no upgrade catalyst: consensus operating income sits 2.1% above the guided midpoint.</a:t>
             </a:r>
             <a:endParaRPr lang="en-US" sz="870" dirty="0"/>
           </a:p>
@@ -1681,7 +1681,7 @@
                 <a:ea typeface="Nunito" pitchFamily="34" charset="-122"/>
                 <a:cs typeface="Nunito" pitchFamily="34" charset="-120"/>
               </a:rPr>
-              <a:t>2027 CFM56 aftermarket growth rests on price alone, while capex rises above 6% of sales.</a:t>
+              <a:t>Jet fuel above $100, a longer French surtax and GE’s caution feed workscope and pricing fears.</a:t>
             </a:r>
             <a:endParaRPr lang="en-US" sz="870" dirty="0"/>
           </a:p>
@@ -2405,7 +2405,7 @@
                 <a:ea typeface="Nunito" pitchFamily="34" charset="-122"/>
                 <a:cs typeface="Nunito" pitchFamily="34" charset="-120"/>
               </a:rPr>
-              <a:t>The quarter was sound, and the 2026 targets held even though a LEAP-1B maintenance-contract profit release in the low hundreds of millions of euros slipped into 2027. Investors wanted more: no upgrade, a CFM56 aftermarket that grows only through price in 2027, capital spending stepping up to above 6% of sales and a French surtax extended into 2027. Management answered the fear of shrinking workscopes directly: they should stay at today’s high level.</a:t>
+              <a:t>The quarter was solid: revenue matched consensus and the civil engine aftermarket kept growing strongly. But unchanged guidance offers no catalyst for upgrades, with consensus operating income already above the range. Near term, jet fuel at $100 or more, the proposed extension of the French surtax and GE’s caution feed fears of workscope compression and weaker pricing. The call pushed back: workscopes should hold at today’s high level, with pricing intact.</a:t>
             </a:r>
             <a:endParaRPr lang="en-US" sz="870" dirty="0"/>
           </a:p>
@@ -2566,7 +2566,7 @@
                 <a:ea typeface="Nunito" pitchFamily="34" charset="-122"/>
                 <a:cs typeface="Nunito" pitchFamily="34" charset="-120"/>
               </a:rPr>
-              <a:t>Group revenue matched the company-compiled consensus within 0.1% and Equipment &amp; Defense beat by 2.5% on guided bombs, optronics, navigation and missile seekers. Aircraft Interiors missed by 1.3%, as seat certification still paces deliveries. The two bars on the right carry the message: confirmed targets sit about 2% below consensus, so estimates edge down rather than up into the full-year results.</a:t>
+              <a:t>Group revenue matched the company-compiled consensus within 0.1% and Equipment &amp; Defense beat by 2.5% on guided bombs, optronics, navigation and missile seekers. Aircraft Interiors missed by 1.3%, as seat certification still paces deliveries. The two bars on the right carry the message: confirmed targets sit about 2% below consensus, so estimates edge down rather than up.</a:t>
             </a:r>
             <a:endParaRPr lang="en-US" sz="870" dirty="0"/>
           </a:p>
@@ -2647,7 +2647,7 @@
                 <a:ea typeface="Nunito" pitchFamily="34" charset="-122"/>
                 <a:cs typeface="Nunito" pitchFamily="34" charset="-120"/>
               </a:rPr>
-              <a:t>We stay positive on Safran and would build positions on this weakness. The earnings path we underwrite is intact: 2026 operating income of EUR 6.4bn to EUR 6.5bn reached without the LEAP-1B profit release, which now adds to 2027, and a 2028 target of EUR 7bn to EUR 7.5bn that management said in July may be revisited. The debate has moved to 2027 aftermarket growth, now framed as CFM56 price plus LEAP volume. The catalyst is 2027 guidance at the full-year results in February. Near term, jet fuel and French tax headlines can keep the shares under pressure.</a:t>
+              <a:t>We stay positive on Safran: the structural case is intact and we would use near-term weakness to build positions. The earnings path we underwrite holds: 2026 operating income of EUR 6.4bn to EUR 6.5bn reached without the LEAP-1B profit release, which now adds to 2027, and a 2028 target of EUR 7bn to EUR 7.5bn that management said in July may be revisited. The debate has moved to the durability of aftermarket pricing and workscopes. The catalyst is 2027 guidance at the full-year results in February. Until then, geopolitics, jet fuel and the French surtax can keep the shares weak.</a:t>
             </a:r>
             <a:endParaRPr lang="en-US" sz="870" dirty="0"/>
           </a:p>
@@ -2805,7 +2805,7 @@
         <p:spPr>
           <a:xfrm>
             <a:off x="3963924" y="9060282"/>
-            <a:ext cx="3058668" cy="784479"/>
+            <a:ext cx="3058668" cy="627583"/>
           </a:xfrm>
           <a:prstGeom prst="rect">
             <a:avLst/>
@@ -2832,7 +2832,7 @@
                 <a:ea typeface="Nunito" pitchFamily="34" charset="-122"/>
                 <a:cs typeface="Nunito" pitchFamily="34" charset="-120"/>
               </a:rPr>
-              <a:t>CFM56 retirements running above the 3% baseline assumed for 2027, or shop visits falling below the 2,400 plateau; the French surtax kept at the 2026 rate, worth EUR 500m or more in 2027; capex above 6% of sales eroding cash conversion.</a:t>
+              <a:t>Evidence of workscope compression or softer CFM56 pricing in Q4 as airlines absorb jet fuel at $100 or more; the French surtax kept at the 2026 rate, worth EUR 500m or more in 2027; capex above 6% of sales eroding cash conversion.</a:t>
             </a:r>
             <a:endParaRPr lang="en-US" sz="870" dirty="0"/>
           </a:p>
@@ -3233,7 +3233,7 @@
                 <a:ea typeface="Nunito" pitchFamily="34" charset="-122"/>
                 <a:cs typeface="Nunito" pitchFamily="34" charset="-120"/>
               </a:rPr>
-              <a:t>Safran confirmed its 2026 targets: revenue growth in the mid-teens, recurring operating income of EUR 6.4bn to EUR 6.5bn and free cash flow of EUR 4.7bn to EUR 4.9bn, despite moving a LEAP-1B profit release in the low hundreds of millions of euros to 2027. Spare parts should rise by the mid to high 20s in Q4 and the mid-20s for the year. For 2027, management expects CFM56 shop visits flat at 2,400 and workscopes stable at today’s high level, so growth comes from price and LEAP. Capex will exceed 6% of sales every year, and the draft 2027 budget extends the surtax, at a cost of around EUR 400m.</a:t>
+              <a:t>Safran confirmed its 2026 targets: revenue growth in the mid-teens, recurring operating income of EUR 6.4bn to EUR 6.5bn and free cash flow of EUR 4.7bn to EUR 4.9bn, despite moving a LEAP-1B profit release in the low hundreds of millions of euros to 2027. Most airlines pass part of the fuel cost on to fares and none has asked to defer deliveries. For 2027, management expects CFM56 shop visits flat at 2,400 and workscopes stable at today’s high level, so growth comes from price and LEAP. Capex will exceed 6% of sales every year, and the draft 2027 budget extends the surtax, at a cost of around EUR 400m.</a:t>
             </a:r>
             <a:endParaRPr lang="en-US" sz="870" dirty="0"/>
           </a:p>

</xml_diff>

<commit_message>
SAF Q3 2026: jet fuel quote on page 1, short management quotes in the text
Co-Authored-By: Claude Opus 5.5 <noreply@anthropic.com>
Claude-Session: https://claude.ai/code/session_014d3kFaWCeVNznnbSptWmJY
</commit_message>
<xml_diff>
--- a/reports/SAF_Q3_2026/Earnings_Update_SAF_Q32026.pptx
+++ b/reports/SAF_Q3_2026/Earnings_Update_SAF_Q32026.pptx
@@ -1360,7 +1360,7 @@
                 <a:ea typeface="Nunito" pitchFamily="34" charset="-122"/>
                 <a:cs typeface="Nunito" pitchFamily="34" charset="-120"/>
               </a:rPr>
-              <a:t>“That’s what we see, and this is why we are fully confident and basically the end of the year is somehow ballistic now. We are very confident in 2027, and we are still confident in 2028.”</a:t>
+              <a:t>“This [the jet fuel price increase] will eat into the profits of the airlines in 2026, but globally, when we compound all the profits of all the airlines, we believe, overall, they are going to stay positive.”</a:t>
             </a:r>
             <a:endParaRPr lang="en-US" sz="980" dirty="0"/>
           </a:p>
@@ -2405,7 +2405,7 @@
                 <a:ea typeface="Nunito" pitchFamily="34" charset="-122"/>
                 <a:cs typeface="Nunito" pitchFamily="34" charset="-120"/>
               </a:rPr>
-              <a:t>The quarter was solid: revenue matched consensus and the civil engine aftermarket kept growing strongly. But unchanged guidance offers no catalyst for upgrades, with consensus operating income already above the range. Near term, jet fuel at $100 or more, the proposed extension of the French surtax and GE’s caution feed fears of workscope compression and weaker pricing. The call pushed back: workscopes should hold at today’s high level, with pricing intact.</a:t>
+              <a:t>The quarter was solid: revenue matched consensus and the civil engine aftermarket kept growing strongly. But unchanged guidance offers no catalyst for upgrades, with consensus operating income already above the range. Near term, jet fuel at $100 or more, the proposed extension of the French surtax and GE’s caution feed fears of workscope compression and weaker pricing. The call pushed back: management expects workscopes to “remain at this high level next year”.</a:t>
             </a:r>
             <a:endParaRPr lang="en-US" sz="870" dirty="0"/>
           </a:p>
@@ -3110,7 +3110,7 @@
                 <a:ea typeface="Nunito" pitchFamily="34" charset="-122"/>
                 <a:cs typeface="Nunito" pitchFamily="34" charset="-120"/>
               </a:rPr>
-              <a:t>Revenue reached EUR 9.0bn, up 14.7% reported and 13.4% organically, in line with the EUR 8.99bn company-compiled consensus; currency added 1.1 points and scope was neutral. Propulsion revenue rose 13% organically to EUR 4.6bn. Civil engine spare parts grew 17% in dollars, below the 24% over nine months because of a strong Q3 2025 base, but up 4% on the second quarter, helped by CFM56 and LEAP pricing. Services grew 19%, led by LEAP maintenance contracts, while military engines declined on the Rafale delivery schedule. LEAP deliveries reached 535, up 5%, and 1,565 over nine months, up 26%, on track for more than 2,100 this year.</a:t>
+              <a:t>Revenue reached EUR 9.0bn, up 14.7% reported and 13.4% organically, in line with the EUR 8.99bn company-compiled consensus; currency added 1.1 points and scope was neutral. Propulsion revenue rose 13% organically to EUR 4.6bn. Civil engine spare parts grew 17% in dollars, showing “no sign of deceleration” according to management: the gap with 24% over nine months reflects a strong Q3 2025 base, and sales rose 4% on Q2. Services grew 19%, led by LEAP maintenance contracts, while military engines declined on the Rafale delivery schedule. LEAP deliveries reached 535, up 5%, and 1,565 over nine months, up 26%, on track for more than 2,100 this year.</a:t>
             </a:r>
             <a:endParaRPr lang="en-US" sz="870" dirty="0"/>
           </a:p>
@@ -3206,7 +3206,7 @@
         <p:spPr>
           <a:xfrm>
             <a:off x="539496" y="3792931"/>
-            <a:ext cx="6483096" cy="802767"/>
+            <a:ext cx="6483096" cy="959663"/>
           </a:xfrm>
           <a:prstGeom prst="rect">
             <a:avLst/>
@@ -3233,7 +3233,7 @@
                 <a:ea typeface="Nunito" pitchFamily="34" charset="-122"/>
                 <a:cs typeface="Nunito" pitchFamily="34" charset="-120"/>
               </a:rPr>
-              <a:t>Safran confirmed its 2026 targets: revenue growth in the mid-teens, recurring operating income of EUR 6.4bn to EUR 6.5bn and free cash flow of EUR 4.7bn to EUR 4.9bn, despite moving a LEAP-1B profit release in the low hundreds of millions of euros to 2027. Most airlines pass part of the fuel cost on to fares and none has asked to defer deliveries. For 2027, management expects CFM56 shop visits flat at 2,400 and workscopes stable at today’s high level, so growth comes from price and LEAP. Capex will exceed 6% of sales every year, and the draft 2027 budget extends the surtax, at a cost of around EUR 400m.</a:t>
+              <a:t>Safran confirmed its 2026 targets: revenue growth in the mid-teens, recurring operating income of EUR 6.4bn to EUR 6.5bn and free cash flow of EUR 4.7bn to EUR 4.9bn, despite moving a LEAP-1B profit release in the low hundreds of millions of euros to 2027. Demand for shop visits still “exceeds the available capacity” and no airline has asked to defer deliveries. For 2027, management expects CFM56 shop visits flat at 2,400 and workscopes stable at today’s high level, so growth comes from price and LEAP. Capex will exceed 6% of sales every year, and the draft 2027 budget extends the surtax, at a cost of around EUR 400m.</a:t>
             </a:r>
             <a:endParaRPr lang="en-US" sz="870" dirty="0"/>
           </a:p>
@@ -3247,7 +3247,7 @@
         </p:nvSpPr>
         <p:spPr>
           <a:xfrm>
-            <a:off x="539496" y="4711827"/>
+            <a:off x="539496" y="4868723"/>
             <a:ext cx="6483096" cy="219456"/>
           </a:xfrm>
           <a:prstGeom prst="rect">
@@ -3286,7 +3286,7 @@
         </p:nvSpPr>
         <p:spPr>
           <a:xfrm>
-            <a:off x="539496" y="4958715"/>
+            <a:off x="539496" y="5115611"/>
             <a:ext cx="6483096" cy="182880"/>
           </a:xfrm>
           <a:prstGeom prst="rect">
@@ -3339,7 +3339,7 @@
         </p:nvSpPr>
         <p:spPr>
           <a:xfrm>
-            <a:off x="539496" y="5141595"/>
+            <a:off x="539496" y="5298491"/>
             <a:ext cx="6483096" cy="118872"/>
           </a:xfrm>
           <a:prstGeom prst="rect">
@@ -3389,7 +3389,7 @@
         </p:blipFill>
         <p:spPr>
           <a:xfrm>
-            <a:off x="928482" y="5306187"/>
+            <a:off x="928482" y="5463083"/>
             <a:ext cx="5705124" cy="3413946"/>
           </a:xfrm>
           <a:prstGeom prst="rect">
@@ -3405,7 +3405,7 @@
         </p:nvSpPr>
         <p:spPr>
           <a:xfrm>
-            <a:off x="539496" y="8774997"/>
+            <a:off x="539496" y="8931893"/>
             <a:ext cx="6483096" cy="802767"/>
           </a:xfrm>
           <a:prstGeom prst="rect">

</xml_diff>

<commit_message>
SAF Q3 2026: plain positive stance, today's share price fall on page 1
Co-Authored-By: Claude Opus 5.5 <noreply@anthropic.com>
Claude-Session: https://claude.ai/code/session_014d3kFaWCeVNznnbSptWmJY
</commit_message>
<xml_diff>
--- a/reports/SAF_Q3_2026/Earnings_Update_SAF_Q32026.pptx
+++ b/reports/SAF_Q3_2026/Earnings_Update_SAF_Q32026.pptx
@@ -2378,7 +2378,7 @@
         <p:spPr>
           <a:xfrm>
             <a:off x="539496" y="4477715"/>
-            <a:ext cx="6483096" cy="645871"/>
+            <a:ext cx="6483096" cy="802767"/>
           </a:xfrm>
           <a:prstGeom prst="rect">
             <a:avLst/>
@@ -2405,7 +2405,7 @@
                 <a:ea typeface="Nunito" pitchFamily="34" charset="-122"/>
                 <a:cs typeface="Nunito" pitchFamily="34" charset="-120"/>
               </a:rPr>
-              <a:t>The quarter was solid: revenue matched consensus and the civil engine aftermarket kept growing strongly. But unchanged guidance offers no catalyst for upgrades, with consensus operating income already above the range. Near term, jet fuel at $100 or more, the proposed extension of the French surtax and GE’s caution feed fears of workscope compression and weaker pricing. The call pushed back: management expects workscopes to “remain at this high level next year”.</a:t>
+              <a:t>The shares fell 6.2% today, and 9.7% over two sessions, although the quarter was solid: revenue matched consensus and the civil aftermarket kept growing. But unchanged guidance offers no catalyst for upgrades, with consensus operating income already above the range. Near term, jet fuel at $100 or more, the proposed extension of the French surtax and GE’s caution feed fears of workscope compression and weaker pricing. The call pushed back: management expects workscopes to “remain at this high level next year”.</a:t>
             </a:r>
             <a:endParaRPr lang="en-US" sz="870" dirty="0"/>
           </a:p>
@@ -2419,7 +2419,7 @@
         </p:nvSpPr>
         <p:spPr>
           <a:xfrm>
-            <a:off x="539496" y="5203139"/>
+            <a:off x="539496" y="5360035"/>
             <a:ext cx="6483096" cy="182880"/>
           </a:xfrm>
           <a:prstGeom prst="rect">
@@ -2472,7 +2472,7 @@
         </p:nvSpPr>
         <p:spPr>
           <a:xfrm>
-            <a:off x="539496" y="5386019"/>
+            <a:off x="539496" y="5542915"/>
             <a:ext cx="6483096" cy="118872"/>
           </a:xfrm>
           <a:prstGeom prst="rect">
@@ -2522,7 +2522,7 @@
         </p:blipFill>
         <p:spPr>
           <a:xfrm>
-            <a:off x="1641622" y="5550611"/>
+            <a:off x="1641622" y="5707507"/>
             <a:ext cx="4278843" cy="1334999"/>
           </a:xfrm>
           <a:prstGeom prst="rect">
@@ -2538,7 +2538,7 @@
         </p:nvSpPr>
         <p:spPr>
           <a:xfrm>
-            <a:off x="539496" y="6940474"/>
+            <a:off x="539496" y="7097370"/>
             <a:ext cx="6483096" cy="645871"/>
           </a:xfrm>
           <a:prstGeom prst="rect">
@@ -2580,7 +2580,7 @@
         </p:nvSpPr>
         <p:spPr>
           <a:xfrm>
-            <a:off x="539496" y="7702474"/>
+            <a:off x="539496" y="7859370"/>
             <a:ext cx="6483096" cy="219456"/>
           </a:xfrm>
           <a:prstGeom prst="rect">
@@ -2619,7 +2619,7 @@
         </p:nvSpPr>
         <p:spPr>
           <a:xfrm>
-            <a:off x="539496" y="7949362"/>
+            <a:off x="539496" y="8106258"/>
             <a:ext cx="6483096" cy="802767"/>
           </a:xfrm>
           <a:prstGeom prst="rect">
@@ -2647,7 +2647,7 @@
                 <a:ea typeface="Nunito" pitchFamily="34" charset="-122"/>
                 <a:cs typeface="Nunito" pitchFamily="34" charset="-120"/>
               </a:rPr>
-              <a:t>We stay positive on Safran: the structural case is intact and we would use near-term weakness to build positions. The earnings path we underwrite holds: 2026 operating income of EUR 6.4bn to EUR 6.5bn reached without the LEAP-1B profit release, which now adds to 2027, and a 2028 target of EUR 7bn to EUR 7.5bn that management said in July may be revisited. The debate has moved to the durability of aftermarket pricing and workscopes. The catalyst is 2027 guidance at the full-year results in February. Until then, geopolitics, jet fuel and the French surtax can keep the shares weak.</a:t>
+              <a:t>We stay positive on Safran: the structural case is intact. The earnings path we underwrite holds: 2026 operating income of EUR 6.4bn to EUR 6.5bn reached without the LEAP-1B profit release, which now adds to 2027, and a 2028 target of EUR 7bn to EUR 7.5bn that management said in July may be revisited. The debate has moved to the durability of aftermarket pricing and workscopes. The catalyst is 2027 guidance at the full-year results in February. Until then, geopolitics, jet fuel and the French surtax can keep the shares weak.</a:t>
             </a:r>
             <a:endParaRPr lang="en-US" sz="870" dirty="0"/>
           </a:p>
@@ -2661,7 +2661,7 @@
         </p:nvSpPr>
         <p:spPr>
           <a:xfrm>
-            <a:off x="3781044" y="8868258"/>
+            <a:off x="3781044" y="9025154"/>
             <a:ext cx="0" cy="985647"/>
           </a:xfrm>
           <a:prstGeom prst="line">
@@ -2684,7 +2684,7 @@
         </p:nvSpPr>
         <p:spPr>
           <a:xfrm>
-            <a:off x="539496" y="8868258"/>
+            <a:off x="539496" y="9025154"/>
             <a:ext cx="3058668" cy="155448"/>
           </a:xfrm>
           <a:prstGeom prst="rect">
@@ -2723,7 +2723,7 @@
         </p:nvSpPr>
         <p:spPr>
           <a:xfrm>
-            <a:off x="539496" y="9060282"/>
+            <a:off x="539496" y="9217178"/>
             <a:ext cx="3058668" cy="784479"/>
           </a:xfrm>
           <a:prstGeom prst="rect">
@@ -2765,7 +2765,7 @@
         </p:nvSpPr>
         <p:spPr>
           <a:xfrm>
-            <a:off x="3963924" y="8868258"/>
+            <a:off x="3963924" y="9025154"/>
             <a:ext cx="3058668" cy="155448"/>
           </a:xfrm>
           <a:prstGeom prst="rect">
@@ -2804,7 +2804,7 @@
         </p:nvSpPr>
         <p:spPr>
           <a:xfrm>
-            <a:off x="3963924" y="9060282"/>
+            <a:off x="3963924" y="9217178"/>
             <a:ext cx="3058668" cy="627583"/>
           </a:xfrm>
           <a:prstGeom prst="rect">

</xml_diff>

<commit_message>
SAF Q3 2026: tighten page-1 paragraph to fit the PowerPoint layout
Co-Authored-By: Claude Opus 5.5 <noreply@anthropic.com>
Claude-Session: https://claude.ai/code/session_014d3kFaWCeVNznnbSptWmJY
</commit_message>
<xml_diff>
--- a/reports/SAF_Q3_2026/Earnings_Update_SAF_Q32026.pptx
+++ b/reports/SAF_Q3_2026/Earnings_Update_SAF_Q32026.pptx
@@ -2378,7 +2378,7 @@
         <p:spPr>
           <a:xfrm>
             <a:off x="539496" y="4477715"/>
-            <a:ext cx="6483096" cy="802767"/>
+            <a:ext cx="6483096" cy="645871"/>
           </a:xfrm>
           <a:prstGeom prst="rect">
             <a:avLst/>
@@ -2405,7 +2405,7 @@
                 <a:ea typeface="Nunito" pitchFamily="34" charset="-122"/>
                 <a:cs typeface="Nunito" pitchFamily="34" charset="-120"/>
               </a:rPr>
-              <a:t>The shares fell 6.2% today, and 9.7% over two sessions, although the quarter was solid: revenue matched consensus and the civil aftermarket kept growing. But unchanged guidance offers no catalyst for upgrades, with consensus operating income already above the range. Near term, jet fuel at $100 or more, the proposed extension of the French surtax and GE’s caution feed fears of workscope compression and weaker pricing. The call pushed back: management expects workscopes to “remain at this high level next year”.</a:t>
+              <a:t>The shares fell 6.2% today although the quarter was solid: revenue matched consensus and the civil aftermarket kept growing. But unchanged guidance offers no catalyst for upgrades, with consensus already above the range. Jet fuel at $100 or more, the proposed extension of the French surtax and GE’s caution feed fears of workscope compression and weaker pricing. The call pushed back: management expects workscopes to “remain at this high level next year”.</a:t>
             </a:r>
             <a:endParaRPr lang="en-US" sz="870" dirty="0"/>
           </a:p>
@@ -2419,7 +2419,7 @@
         </p:nvSpPr>
         <p:spPr>
           <a:xfrm>
-            <a:off x="539496" y="5360035"/>
+            <a:off x="539496" y="5203139"/>
             <a:ext cx="6483096" cy="182880"/>
           </a:xfrm>
           <a:prstGeom prst="rect">
@@ -2472,7 +2472,7 @@
         </p:nvSpPr>
         <p:spPr>
           <a:xfrm>
-            <a:off x="539496" y="5542915"/>
+            <a:off x="539496" y="5386019"/>
             <a:ext cx="6483096" cy="118872"/>
           </a:xfrm>
           <a:prstGeom prst="rect">
@@ -2522,7 +2522,7 @@
         </p:blipFill>
         <p:spPr>
           <a:xfrm>
-            <a:off x="1641622" y="5707507"/>
+            <a:off x="1641622" y="5550611"/>
             <a:ext cx="4278843" cy="1334999"/>
           </a:xfrm>
           <a:prstGeom prst="rect">
@@ -2538,7 +2538,7 @@
         </p:nvSpPr>
         <p:spPr>
           <a:xfrm>
-            <a:off x="539496" y="7097370"/>
+            <a:off x="539496" y="6940474"/>
             <a:ext cx="6483096" cy="645871"/>
           </a:xfrm>
           <a:prstGeom prst="rect">
@@ -2580,7 +2580,7 @@
         </p:nvSpPr>
         <p:spPr>
           <a:xfrm>
-            <a:off x="539496" y="7859370"/>
+            <a:off x="539496" y="7702474"/>
             <a:ext cx="6483096" cy="219456"/>
           </a:xfrm>
           <a:prstGeom prst="rect">
@@ -2619,7 +2619,7 @@
         </p:nvSpPr>
         <p:spPr>
           <a:xfrm>
-            <a:off x="539496" y="8106258"/>
+            <a:off x="539496" y="7949362"/>
             <a:ext cx="6483096" cy="802767"/>
           </a:xfrm>
           <a:prstGeom prst="rect">
@@ -2661,7 +2661,7 @@
         </p:nvSpPr>
         <p:spPr>
           <a:xfrm>
-            <a:off x="3781044" y="9025154"/>
+            <a:off x="3781044" y="8868258"/>
             <a:ext cx="0" cy="985647"/>
           </a:xfrm>
           <a:prstGeom prst="line">
@@ -2684,7 +2684,7 @@
         </p:nvSpPr>
         <p:spPr>
           <a:xfrm>
-            <a:off x="539496" y="9025154"/>
+            <a:off x="539496" y="8868258"/>
             <a:ext cx="3058668" cy="155448"/>
           </a:xfrm>
           <a:prstGeom prst="rect">
@@ -2723,7 +2723,7 @@
         </p:nvSpPr>
         <p:spPr>
           <a:xfrm>
-            <a:off x="539496" y="9217178"/>
+            <a:off x="539496" y="9060282"/>
             <a:ext cx="3058668" cy="784479"/>
           </a:xfrm>
           <a:prstGeom prst="rect">
@@ -2765,7 +2765,7 @@
         </p:nvSpPr>
         <p:spPr>
           <a:xfrm>
-            <a:off x="3963924" y="9025154"/>
+            <a:off x="3963924" y="8868258"/>
             <a:ext cx="3058668" cy="155448"/>
           </a:xfrm>
           <a:prstGeom prst="rect">
@@ -2804,7 +2804,7 @@
         </p:nvSpPr>
         <p:spPr>
           <a:xfrm>
-            <a:off x="3963924" y="9217178"/>
+            <a:off x="3963924" y="9060282"/>
             <a:ext cx="3058668" cy="627583"/>
           </a:xfrm>
           <a:prstGeom prst="rect">

</xml_diff>